<commit_message>
docs: modèle du live 1 vérifié sur HF (Qwen3-0.6B-Q4_K_M, 397 MB) + deck aligné
</commit_message>
<xml_diff>
--- a/presentation/llm-agentique-local.pptx
+++ b/presentation/llm-agentique-local.pptx
@@ -136,14 +136,14 @@
   <p:extLst>
     <p:ext uri="{521415D9-36F7-43E2-AB2F-B90AF26B5E84}">
       <p14:sectionLst xmlns:p14="http://schemas.microsoft.com/office/powerpoint/2010/main">
-        <p14:section name="Ouverture" id="{b8de86b6-0e74-8063-9ae3-08f761b7b67f}">
+        <p14:section name="Ouverture" id="{838a40ad-aacd-d038-5a18-4a3342814a1c}">
           <p14:sldIdLst>
             <p14:sldId id="256"/>
             <p14:sldId id="257"/>
             <p14:sldId id="258"/>
           </p14:sldIdLst>
         </p14:section>
-        <p14:section name="Acte 1 — Comprendre" id="{5d948b62-8c3c-3bfd-c34d-f3b2fd0e5e3f}">
+        <p14:section name="Acte 1 — Comprendre" id="{17a94555-deb2-6c2c-d756-251adad4459f}">
           <p14:sldIdLst>
             <p14:sldId id="259"/>
             <p14:sldId id="260"/>
@@ -157,7 +157,7 @@
             <p14:sldId id="268"/>
           </p14:sldIdLst>
         </p14:section>
-        <p14:section name="Acte 2 — Agir" id="{6c9bc8c0-a3c1-88f9-c770-a1ba46e222ae}">
+        <p14:section name="Acte 2 — Agir" id="{848b0dd9-eed5-cbbe-d092-cf7d165f0975}">
           <p14:sldIdLst>
             <p14:sldId id="269"/>
             <p14:sldId id="270"/>
@@ -168,7 +168,7 @@
             <p14:sldId id="275"/>
           </p14:sldIdLst>
         </p14:section>
-        <p14:section name="Acte 3 — Étendre" id="{c19f1bdd-7aed-8b57-2e59-a6060f0bbb57}">
+        <p14:section name="Acte 3 — Étendre" id="{023c78c9-6bc7-12ed-a6da-74a6c931375a}">
           <p14:sldIdLst>
             <p14:sldId id="276"/>
             <p14:sldId id="277"/>
@@ -178,7 +178,7 @@
             <p14:sldId id="281"/>
           </p14:sldIdLst>
         </p14:section>
-        <p14:section name="Clôture" id="{e393df2c-c51d-4db8-f4cb-1fd662a1dfdb}">
+        <p14:section name="Clôture" id="{9a14904b-9e64-90bb-57ac-8acc3f4efa9c}">
           <p14:sldIdLst>
             <p14:sldId id="282"/>
             <p14:sldId id="283"/>
@@ -6275,7 +6275,7 @@
                 <a:ea typeface="Calibri" pitchFamily="34" charset="-122"/>
                 <a:cs typeface="Calibri" pitchFamily="34" charset="-120"/>
               </a:rPr>
-              <a:t>On télécharge un petit modèle (~500 Mo) devant vous. Le temps de ma phrase.</a:t>
+              <a:t>On télécharge un petit modèle (~400 Mo) devant vous. Le temps de ma phrase.</a:t>
             </a:r>
             <a:endParaRPr lang="en-US" sz="1300" dirty="0"/>
           </a:p>

</xml_diff>

<commit_message>
feat: démo avec ticket de caisse web, ticket client, AGENTS.md et reset.sh ; live 2 adapté
</commit_message>
<xml_diff>
--- a/presentation/llm-agentique-local.pptx
+++ b/presentation/llm-agentique-local.pptx
@@ -135,13 +135,13 @@
   <p:extLst>
     <p:ext uri="{521415D9-36F7-43E2-AB2F-B90AF26B5E84}">
       <p14:sectionLst xmlns:p14="http://schemas.microsoft.com/office/powerpoint/2010/main">
-        <p14:section name="Ouverture" id="{1063d96b-5af2-ceb4-1aee-a97bac86c8f3}">
+        <p14:section name="Ouverture" id="{eabf1656-ed32-99d3-d685-b7fdbe67cce7}">
           <p14:sldIdLst>
             <p14:sldId id="256"/>
             <p14:sldId id="257"/>
           </p14:sldIdLst>
         </p14:section>
-        <p14:section name="Acte 1 — Exécuter" id="{a580914f-96e2-6190-fd67-a7d2707f315e}">
+        <p14:section name="Acte 1 — Exécuter" id="{4ec3c53c-805b-aaa9-10d4-b0e3eef7bdab}">
           <p14:sldIdLst>
             <p14:sldId id="258"/>
             <p14:sldId id="259"/>
@@ -156,7 +156,7 @@
             <p14:sldId id="268"/>
           </p14:sldIdLst>
         </p14:section>
-        <p14:section name="Acte 2 — Orchestrer" id="{e800f2fb-3ea5-9c5a-3ead-0526e2c500ab}">
+        <p14:section name="Acte 2 — Orchestrer" id="{4c432e4e-25d0-cedd-a0af-13ea041bd17d}">
           <p14:sldIdLst>
             <p14:sldId id="269"/>
             <p14:sldId id="270"/>
@@ -170,14 +170,14 @@
             <p14:sldId id="278"/>
           </p14:sldIdLst>
         </p14:section>
-        <p14:section name="Acte 3 — Explorer" id="{03b67408-eb18-83cb-b0b1-b96983c9b2c6}">
+        <p14:section name="Acte 3 — Explorer" id="{414eeebe-6d61-2ab3-bcd1-b51ae621485b}">
           <p14:sldIdLst>
             <p14:sldId id="279"/>
             <p14:sldId id="280"/>
             <p14:sldId id="281"/>
           </p14:sldIdLst>
         </p14:section>
-        <p14:section name="Clôture" id="{2eaa803e-0c07-48d2-7f4d-82e25bff2453}">
+        <p14:section name="Clôture" id="{0f38ea41-ed12-b8cb-b818-3b70616dc9df}">
           <p14:sldIdLst>
             <p14:sldId id="282"/>
             <p14:sldId id="283"/>
@@ -3235,7 +3235,7 @@
           <a:p>
             <a:r>
               <a:rPr lang="en-US" dirty="0"/>
-              <a:t>LIVE 2 (10 min). Script : SCENARIOS.md. Ne PAS révéler le bug avant le git diff. Pendant que l'agent travaille, montrer le log serveur : prompt eval time petit (seul le suffixe est recalculé) grâce au cache. Punchline : curl /metrics — chiffres du jour à relever avant la session (compteurs cumulés depuis le démarrage du serveur).</a:t>
+              <a:t>LIVE 2 (10 min). Script : SCENARIOS.md. Avant : demo/reset.sh et python3 demo/web/server.py (http://127.0.0.1:8000). Prompt : « Corrige le ticket demo/TICKET.md. » (plan B : « Les tests de demo/ sont rouges, rends-les verts. »). Ne PAS révéler le bug avant le git diff. Pendant que l'agent travaille, montrer le log serveur : prompt eval time petit (seul le suffixe est recalculé) grâce au cache. Punchline : curl /metrics — chiffres du jour à relever avant la session (compteurs cumulés depuis le démarrage du serveur).</a:t>
             </a:r>
             <a:endParaRPr lang="en-US" dirty="0"/>
           </a:p>
@@ -18390,7 +18390,7 @@
                 <a:ea typeface="Cambria" pitchFamily="34" charset="-122"/>
                 <a:cs typeface="Cambria" pitchFamily="34" charset="-120"/>
               </a:rPr>
-              <a:t>OpenCode corrige un bug, 100 % local</a:t>
+              <a:t>Un ticket client corrigé par l'agent, 100 % local</a:t>
             </a:r>
             <a:endParaRPr lang="en-US" sz="3600" dirty="0"/>
           </a:p>
@@ -18488,7 +18488,7 @@
                 <a:ea typeface="Calibri" pitchFamily="34" charset="-122"/>
                 <a:cs typeface="Calibri" pitchFamily="34" charset="-120"/>
               </a:rPr>
-              <a:t>Le constat</a:t>
+              <a:t>Le symptôme</a:t>
             </a:r>
             <a:endParaRPr lang="en-US" sz="1700" dirty="0"/>
           </a:p>
@@ -18527,7 +18527,7 @@
                 <a:ea typeface="Calibri" pitchFamily="34" charset="-122"/>
                 <a:cs typeface="Calibri" pitchFamily="34" charset="-120"/>
               </a:rPr>
-              <a:t>python3 -m unittest dans demo/ : 9 tests, 3 rouges. Un bug de facturation. Je ne dis pas où.</a:t>
+              <a:t>Page ticket : « Remise (9 %) — annoncé 10 % », 1,44 € facturés en trop. L'agent reçoit seulement TICKET.md.</a:t>
             </a:r>
             <a:endParaRPr lang="en-US" sz="1400" dirty="0"/>
           </a:p>
@@ -18625,7 +18625,7 @@
                 <a:ea typeface="Calibri" pitchFamily="34" charset="-122"/>
                 <a:cs typeface="Calibri" pitchFamily="34" charset="-120"/>
               </a:rPr>
-              <a:t>L'agent travaille</a:t>
+              <a:t>L'agent enquête</a:t>
             </a:r>
             <a:endParaRPr lang="en-US" sz="1700" dirty="0"/>
           </a:p>
@@ -18664,7 +18664,7 @@
                 <a:ea typeface="Calibri" pitchFamily="34" charset="-122"/>
                 <a:cs typeface="Calibri" pitchFamily="34" charset="-120"/>
               </a:rPr>
-              <a:t>read → shell → read → edit → shell. Et le log du serveur montre le cache au travail.</a:t>
+              <a:t>ticket → pricing.py → tests rouges → edit → tests verts. Le log serveur montre le cache au travail.</a:t>
             </a:r>
             <a:endParaRPr lang="en-US" sz="1400" dirty="0"/>
           </a:p>
@@ -18762,7 +18762,7 @@
                 <a:ea typeface="Calibri" pitchFamily="34" charset="-122"/>
                 <a:cs typeface="Calibri" pitchFamily="34" charset="-120"/>
               </a:rPr>
-              <a:t>git diff</a:t>
+              <a:t>F5, puis git diff</a:t>
             </a:r>
             <a:endParaRPr lang="en-US" sz="1700" dirty="0"/>
           </a:p>
@@ -18801,7 +18801,7 @@
                 <a:ea typeface="Calibri" pitchFamily="34" charset="-122"/>
                 <a:cs typeface="Calibri" pitchFamily="34" charset="-120"/>
               </a:rPr>
-              <a:t>Une seule valeur change. « Il n'a pas deviné : il a mesuré. »</a:t>
+              <a:t>La page passe au vert. Une seule valeur a changé : « il n'a pas deviné, il a mesuré ».</a:t>
             </a:r>
             <a:endParaRPr lang="en-US" sz="1400" dirty="0"/>
           </a:p>

</xml_diff>

<commit_message>
chore: retrait de l'outillage d'agent et du glossaire, références aux skills mises à jour
</commit_message>
<xml_diff>
--- a/presentation/llm-agentique-local.pptx
+++ b/presentation/llm-agentique-local.pptx
@@ -135,13 +135,13 @@
   <p:extLst>
     <p:ext uri="{521415D9-36F7-43E2-AB2F-B90AF26B5E84}">
       <p14:sectionLst xmlns:p14="http://schemas.microsoft.com/office/powerpoint/2010/main">
-        <p14:section name="Ouverture" id="{eabf1656-ed32-99d3-d685-b7fdbe67cce7}">
+        <p14:section name="Ouverture" id="{7934075e-2a06-b78b-2f2f-52b0ba604b16}">
           <p14:sldIdLst>
             <p14:sldId id="256"/>
             <p14:sldId id="257"/>
           </p14:sldIdLst>
         </p14:section>
-        <p14:section name="Acte 1 — Exécuter" id="{4ec3c53c-805b-aaa9-10d4-b0e3eef7bdab}">
+        <p14:section name="Acte 1 — Exécuter" id="{40737e1b-c645-267e-11fc-030dad70f66b}">
           <p14:sldIdLst>
             <p14:sldId id="258"/>
             <p14:sldId id="259"/>
@@ -156,7 +156,7 @@
             <p14:sldId id="268"/>
           </p14:sldIdLst>
         </p14:section>
-        <p14:section name="Acte 2 — Orchestrer" id="{4c432e4e-25d0-cedd-a0af-13ea041bd17d}">
+        <p14:section name="Acte 2 — Orchestrer" id="{86a257ad-6e2c-e768-48a0-59352ef909dc}">
           <p14:sldIdLst>
             <p14:sldId id="269"/>
             <p14:sldId id="270"/>
@@ -170,14 +170,14 @@
             <p14:sldId id="278"/>
           </p14:sldIdLst>
         </p14:section>
-        <p14:section name="Acte 3 — Explorer" id="{414eeebe-6d61-2ab3-bcd1-b51ae621485b}">
+        <p14:section name="Acte 3 — Explorer" id="{1dd9575e-ade4-3dae-bdec-6cb36422459b}">
           <p14:sldIdLst>
             <p14:sldId id="279"/>
             <p14:sldId id="280"/>
             <p14:sldId id="281"/>
           </p14:sldIdLst>
         </p14:section>
-        <p14:section name="Clôture" id="{0f38ea41-ed12-b8cb-b818-3b70616dc9df}">
+        <p14:section name="Clôture" id="{bc0d049c-17cb-1cce-7526-f9ea12f8ee02}">
           <p14:sldIdLst>
             <p14:sldId id="282"/>
             <p14:sldId id="283"/>
@@ -13580,7 +13580,7 @@
                 <a:ea typeface="Calibri" pitchFamily="34" charset="-122"/>
                 <a:cs typeface="Calibri" pitchFamily="34" charset="-120"/>
               </a:rPr>
-              <a:t>tokens rien que pour la liste des 49 skills de ce repo</a:t>
+              <a:t>tokens rien que pour décrire 49 skills installées (mesure du 05/10)</a:t>
             </a:r>
             <a:endParaRPr lang="en-US" sz="1300" dirty="0"/>
           </a:p>

</xml_diff>

<commit_message>
feat: URL du repo public et QR code générés dans le deck (slides 28 et 29)
</commit_message>
<xml_diff>
--- a/presentation/llm-agentique-local.pptx
+++ b/presentation/llm-agentique-local.pptx
@@ -135,13 +135,13 @@
   <p:extLst>
     <p:ext uri="{521415D9-36F7-43E2-AB2F-B90AF26B5E84}">
       <p14:sectionLst xmlns:p14="http://schemas.microsoft.com/office/powerpoint/2010/main">
-        <p14:section name="Ouverture" id="{7934075e-2a06-b78b-2f2f-52b0ba604b16}">
+        <p14:section name="Ouverture" id="{78535403-55a1-9f5d-3e40-69a2ba4d600b}">
           <p14:sldIdLst>
             <p14:sldId id="256"/>
             <p14:sldId id="257"/>
           </p14:sldIdLst>
         </p14:section>
-        <p14:section name="Acte 1 — Exécuter" id="{40737e1b-c645-267e-11fc-030dad70f66b}">
+        <p14:section name="Acte 1 — Exécuter" id="{b363df5c-1839-19c4-c4e7-31155130e90d}">
           <p14:sldIdLst>
             <p14:sldId id="258"/>
             <p14:sldId id="259"/>
@@ -156,7 +156,7 @@
             <p14:sldId id="268"/>
           </p14:sldIdLst>
         </p14:section>
-        <p14:section name="Acte 2 — Orchestrer" id="{86a257ad-6e2c-e768-48a0-59352ef909dc}">
+        <p14:section name="Acte 2 — Orchestrer" id="{9a1ffce6-790f-bde5-441a-24881a17282a}">
           <p14:sldIdLst>
             <p14:sldId id="269"/>
             <p14:sldId id="270"/>
@@ -170,14 +170,14 @@
             <p14:sldId id="278"/>
           </p14:sldIdLst>
         </p14:section>
-        <p14:section name="Acte 3 — Explorer" id="{1dd9575e-ade4-3dae-bdec-6cb36422459b}">
+        <p14:section name="Acte 3 — Explorer" id="{a551790b-5518-877b-449b-ff02f11f20a8}">
           <p14:sldIdLst>
             <p14:sldId id="279"/>
             <p14:sldId id="280"/>
             <p14:sldId id="281"/>
           </p14:sldIdLst>
         </p14:section>
-        <p14:section name="Clôture" id="{bc0d049c-17cb-1cce-7526-f9ea12f8ee02}">
+        <p14:section name="Clôture" id="{12aacac5-2bd5-9030-4c6c-f21760f9d4a9}">
           <p14:sldIdLst>
             <p14:sldId id="282"/>
             <p14:sldId id="283"/>
@@ -22174,7 +22174,7 @@
                 <a:ea typeface="Cambria" pitchFamily="34" charset="-122"/>
                 <a:cs typeface="Cambria" pitchFamily="34" charset="-120"/>
               </a:rPr>
-              <a:t>Chez vous ce soir — trois commandes</a:t>
+              <a:t>Chez vous ce soir</a:t>
             </a:r>
             <a:endParaRPr lang="en-US" sz="3000" dirty="0"/>
           </a:p>
@@ -22235,7 +22235,24 @@
                 <a:ea typeface="Courier New" pitchFamily="34" charset="-122"/>
                 <a:cs typeface="Courier New" pitchFamily="34" charset="-120"/>
               </a:rPr>
-              <a:t>$ git clone &lt;le repo de cette présentation&gt;</a:t>
+              <a:t>$ git clone https://github.com/m-max/llm-introduction</a:t>
+            </a:r>
+            <a:endParaRPr lang="en-US" sz="1400" dirty="0"/>
+          </a:p>
+          <a:p>
+            <a:pPr algn="l" indent="0" marL="0">
+              <a:buNone/>
+            </a:pPr>
+            <a:r>
+              <a:rPr lang="en-US" sz="1400" dirty="0">
+                <a:solidFill>
+                  <a:srgbClr val="E6F1EC"/>
+                </a:solidFill>
+                <a:latin typeface="Courier New" pitchFamily="34" charset="0"/>
+                <a:ea typeface="Courier New" pitchFamily="34" charset="-122"/>
+                <a:cs typeface="Courier New" pitchFamily="34" charset="-120"/>
+              </a:rPr>
+              <a:t>$ cd llm-introduction</a:t>
             </a:r>
             <a:endParaRPr lang="en-US" sz="1400" dirty="0"/>
           </a:p>
@@ -22388,23 +22405,25 @@
         </p:nvSpPr>
         <p:spPr>
           <a:xfrm>
-            <a:off x="8138160" y="1463040"/>
-            <a:ext cx="3291840" cy="3291840"/>
+            <a:off x="8138160" y="1371600"/>
+            <a:ext cx="3502152" cy="4023360"/>
           </a:xfrm>
           <a:prstGeom prst="roundRect">
             <a:avLst>
-              <a:gd name="adj" fmla="val 2778"/>
+              <a:gd name="adj" fmla="val 3133"/>
             </a:avLst>
           </a:prstGeom>
           <a:solidFill>
             <a:srgbClr val="FFFFFF"/>
           </a:solidFill>
-          <a:ln w="19050">
-            <a:solidFill>
-              <a:srgbClr val="1B2437"/>
-            </a:solidFill>
-            <a:prstDash val="dash"/>
-          </a:ln>
+          <a:ln/>
+          <a:effectLst>
+            <a:outerShdw sx="100000" sy="100000" kx="0" ky="0" algn="bl" rotWithShape="0" blurRad="76200" dist="25400" dir="5400000">
+              <a:srgbClr val="8A97AC">
+                <a:alpha val="35000"/>
+              </a:srgbClr>
+            </a:outerShdw>
+          </a:effectLst>
         </p:spPr>
       </p:sp>
       <p:sp>
@@ -22415,8 +22434,8 @@
         </p:nvSpPr>
         <p:spPr>
           <a:xfrm>
-            <a:off x="8321040" y="1691640"/>
-            <a:ext cx="2926080" cy="2834640"/>
+            <a:off x="8138160" y="4572000"/>
+            <a:ext cx="3502152" cy="365760"/>
           </a:xfrm>
           <a:prstGeom prst="rect">
             <a:avLst/>
@@ -22432,24 +22451,46 @@
               <a:buNone/>
             </a:pPr>
             <a:r>
-              <a:rPr lang="en-US" sz="1400" dirty="0">
-                <a:solidFill>
-                  <a:srgbClr val="5A6B85"/>
+              <a:rPr lang="en-US" sz="1300" b="1" dirty="0">
+                <a:solidFill>
+                  <a:srgbClr val="028090"/>
                 </a:solidFill>
                 <a:latin typeface="Calibri" pitchFamily="34" charset="0"/>
                 <a:ea typeface="Calibri" pitchFamily="34" charset="-122"/>
                 <a:cs typeface="Calibri" pitchFamily="34" charset="-120"/>
               </a:rPr>
-              <a:t>QR → repo public</a:t>
-            </a:r>
-            <a:endParaRPr lang="en-US" sz="1400" dirty="0"/>
-          </a:p>
+              <a:t>github.com/m-max/llm-introduction</a:t>
+            </a:r>
+            <a:endParaRPr lang="en-US" sz="1300" dirty="0"/>
+          </a:p>
+        </p:txBody>
+      </p:sp>
+      <p:sp>
+        <p:nvSpPr>
+          <p:cNvPr id="9" name="Text 7"/>
+          <p:cNvSpPr/>
+          <p:nvPr/>
+        </p:nvSpPr>
+        <p:spPr>
+          <a:xfrm>
+            <a:off x="8138160" y="4919472"/>
+            <a:ext cx="3502152" cy="320040"/>
+          </a:xfrm>
+          <a:prstGeom prst="rect">
+            <a:avLst/>
+          </a:prstGeom>
+          <a:noFill/>
+          <a:ln/>
+        </p:spPr>
+        <p:txBody>
+          <a:bodyPr wrap="square" lIns="0" tIns="0" rIns="0" bIns="0" rtlCol="0" anchor="ctr"/>
+          <a:lstStyle/>
           <a:p>
             <a:pPr algn="ctr" indent="0" marL="0">
               <a:buNone/>
             </a:pPr>
             <a:r>
-              <a:rPr lang="en-US" sz="1400" dirty="0">
+              <a:rPr lang="en-US" sz="1200" dirty="0">
                 <a:solidFill>
                   <a:srgbClr val="5A6B85"/>
                 </a:solidFill>
@@ -22457,35 +22498,36 @@
                 <a:ea typeface="Calibri" pitchFamily="34" charset="-122"/>
                 <a:cs typeface="Calibri" pitchFamily="34" charset="-120"/>
               </a:rPr>
-              <a:t>github.com/&lt;vous&gt;/llama</a:t>
-            </a:r>
-            <a:endParaRPr lang="en-US" sz="1400" dirty="0"/>
-          </a:p>
-          <a:p>
-            <a:pPr algn="ctr" indent="0" marL="0">
-              <a:buNone/>
-            </a:pPr>
-            <a:endParaRPr lang="en-US" sz="1400" dirty="0"/>
-          </a:p>
-          <a:p>
-            <a:pPr algn="ctr" indent="0" marL="0">
-              <a:buNone/>
-            </a:pPr>
-            <a:r>
-              <a:rPr lang="en-US" sz="1400" dirty="0">
-                <a:solidFill>
-                  <a:srgbClr val="5A6B85"/>
-                </a:solidFill>
-                <a:latin typeface="Calibri" pitchFamily="34" charset="0"/>
-                <a:ea typeface="Calibri" pitchFamily="34" charset="-122"/>
-                <a:cs typeface="Calibri" pitchFamily="34" charset="-120"/>
-              </a:rPr>
-              <a:t>(à générer avant le jour J)</a:t>
-            </a:r>
-            <a:endParaRPr lang="en-US" sz="1400" dirty="0"/>
-          </a:p>
-        </p:txBody>
-      </p:sp>
+              <a:t>public · licence MIT</a:t>
+            </a:r>
+            <a:endParaRPr lang="en-US" sz="1200" dirty="0"/>
+          </a:p>
+        </p:txBody>
+      </p:sp>
+      <p:pic>
+        <p:nvPicPr>
+          <p:cNvPr id="11" name="Image 0" descr="QR code vers https://github.com/m-max/llm-introduction">    </p:cNvPr>
+          <p:cNvPicPr>
+            <a:picLocks noChangeAspect="1"/>
+          </p:cNvPicPr>
+          <p:nvPr/>
+        </p:nvPicPr>
+        <p:blipFill>
+          <a:blip r:embed="rId1"/>
+          <a:stretch>
+            <a:fillRect/>
+          </a:stretch>
+        </p:blipFill>
+        <p:spPr>
+          <a:xfrm>
+            <a:off x="8476488" y="1600200"/>
+            <a:ext cx="2834640" cy="2834640"/>
+          </a:xfrm>
+          <a:prstGeom prst="rect">
+            <a:avLst/>
+          </a:prstGeom>
+        </p:spPr>
+      </p:pic>
       <p:sp>
         <p:nvSpPr>
           <p:cNvPr id="25" name="Slide Number Placeholder 0"/>
@@ -22672,7 +22714,7 @@
                 <a:ea typeface="Calibri" pitchFamily="34" charset="-122"/>
                 <a:cs typeface="Calibri" pitchFamily="34" charset="-120"/>
               </a:rPr>
-              <a:t>repo : github.com/&lt;vous&gt;/llama · licence MIT · tout est rejouable</a:t>
+              <a:t>repo : github.com/m-max/llm-introduction · licence MIT · tout est rejouable</a:t>
             </a:r>
             <a:endParaRPr lang="en-US" sz="1300" dirty="0"/>
           </a:p>

</xml_diff>